<commit_message>
slight modifications for reading and intro to git
</commit_message>
<xml_diff>
--- a/DevOps/Lesson 01 - Intro to Version Control/Intro to Version Control.pptx
+++ b/DevOps/Lesson 01 - Intro to Version Control/Intro to Version Control.pptx
@@ -4255,7 +4255,7 @@
           <a:p>
             <a:fld id="{7A3E0868-4E26-4CDC-8A56-D70E2D8B12FE}" type="datetime3">
               <a:rPr lang="en-US" smtClean="0"/>
-              <a:t>4 June 2026</a:t>
+              <a:t>20 July 2026</a:t>
             </a:fld>
             <a:endParaRPr lang="en-US"/>
           </a:p>
@@ -6816,7 +6816,7 @@
           <a:p>
             <a:fld id="{A7B8021B-6105-4216-96FC-94348F216D0E}" type="datetime3">
               <a:rPr lang="en-US" smtClean="0"/>
-              <a:t>4 June 2026</a:t>
+              <a:t>20 July 2026</a:t>
             </a:fld>
             <a:endParaRPr lang="en-US"/>
           </a:p>
@@ -8513,7 +8513,7 @@
           <a:p>
             <a:fld id="{5D27CFAB-73E6-44A8-B862-B3306344E3F2}" type="datetime3">
               <a:rPr lang="en-US" smtClean="0"/>
-              <a:t>4 June 2026</a:t>
+              <a:t>20 July 2026</a:t>
             </a:fld>
             <a:endParaRPr lang="en-US"/>
           </a:p>
@@ -10303,7 +10303,7 @@
           <a:p>
             <a:fld id="{A9B2E784-A5F5-4301-881B-94AC8DBF9DED}" type="datetime3">
               <a:rPr lang="en-US" smtClean="0"/>
-              <a:t>4 June 2026</a:t>
+              <a:t>20 July 2026</a:t>
             </a:fld>
             <a:endParaRPr lang="en-US"/>
           </a:p>
@@ -10482,7 +10482,7 @@
           <a:p>
             <a:fld id="{18EAB3A5-9E92-4BB9-8F22-9632B4FBEDBA}" type="datetime3">
               <a:rPr lang="en-US" smtClean="0"/>
-              <a:t>4 June 2026</a:t>
+              <a:t>20 July 2026</a:t>
             </a:fld>
             <a:endParaRPr lang="en-US"/>
           </a:p>
@@ -10709,7 +10709,7 @@
           <a:p>
             <a:fld id="{40923810-5FB2-48C9-96CA-1DE2C4773142}" type="datetime3">
               <a:rPr lang="en-US" smtClean="0"/>
-              <a:t>4 June 2026</a:t>
+              <a:t>20 July 2026</a:t>
             </a:fld>
             <a:endParaRPr lang="en-US"/>
           </a:p>
@@ -10999,7 +10999,7 @@
           <a:p>
             <a:fld id="{E50EFF4B-86EB-42FB-93EA-7D8F9CB2466F}" type="datetime3">
               <a:rPr lang="en-US" smtClean="0"/>
-              <a:t>4 June 2026</a:t>
+              <a:t>20 July 2026</a:t>
             </a:fld>
             <a:endParaRPr lang="en-US"/>
           </a:p>
@@ -11611,7 +11611,7 @@
           <a:p>
             <a:fld id="{FB14FC24-E041-45E9-9A72-E5755A86890F}" type="datetime3">
               <a:rPr lang="en-US" smtClean="0"/>
-              <a:t>4 June 2026</a:t>
+              <a:t>20 July 2026</a:t>
             </a:fld>
             <a:endParaRPr lang="en-US"/>
           </a:p>
@@ -12471,7 +12471,7 @@
           <a:p>
             <a:fld id="{98A19125-94A7-4474-858C-FD9C4ABE9DDA}" type="datetime3">
               <a:rPr lang="en-US" smtClean="0"/>
-              <a:t>4 June 2026</a:t>
+              <a:t>20 July 2026</a:t>
             </a:fld>
             <a:endParaRPr lang="en-US"/>
           </a:p>
@@ -13574,7 +13574,7 @@
           <a:p>
             <a:fld id="{3BA0343D-C8D8-43CE-BB79-50DEA219DB07}" type="datetime3">
               <a:rPr lang="en-US" smtClean="0"/>
-              <a:t>4 June 2026</a:t>
+              <a:t>20 July 2026</a:t>
             </a:fld>
             <a:endParaRPr lang="en-US"/>
           </a:p>
@@ -13863,7 +13863,7 @@
           <a:p>
             <a:fld id="{453BD212-0B9F-4987-965F-AC83B2FC354F}" type="datetime3">
               <a:rPr lang="en-US" smtClean="0"/>
-              <a:t>4 June 2026</a:t>
+              <a:t>20 July 2026</a:t>
             </a:fld>
             <a:endParaRPr lang="en-US"/>
           </a:p>
@@ -14108,7 +14108,7 @@
           <a:p>
             <a:fld id="{6DDC931E-8CBE-4A3F-A034-9B6122C6DCDB}" type="datetime3">
               <a:rPr lang="en-US" smtClean="0"/>
-              <a:t>4 June 2026</a:t>
+              <a:t>20 July 2026</a:t>
             </a:fld>
             <a:endParaRPr lang="en-US"/>
           </a:p>
@@ -15874,7 +15874,7 @@
           <a:p>
             <a:fld id="{220AF9C2-5E8A-4308-AE6B-CA9B65007D0E}" type="datetime3">
               <a:rPr lang="en-US" smtClean="0"/>
-              <a:t>4 June 2026</a:t>
+              <a:t>20 July 2026</a:t>
             </a:fld>
             <a:endParaRPr lang="en-US"/>
           </a:p>
@@ -16187,7 +16187,7 @@
           <a:p>
             <a:fld id="{FF31E861-D2AF-431D-860B-DCF67C218052}" type="datetime3">
               <a:rPr lang="en-US" smtClean="0"/>
-              <a:t>4 June 2026</a:t>
+              <a:t>20 July 2026</a:t>
             </a:fld>
             <a:endParaRPr lang="en-US"/>
           </a:p>
@@ -16466,7 +16466,7 @@
           <a:p>
             <a:fld id="{D1DA25B2-AAF1-4C1F-AA38-12D5BFA7D4C8}" type="datetime3">
               <a:rPr lang="en-US" smtClean="0"/>
-              <a:t>4 June 2026</a:t>
+              <a:t>20 July 2026</a:t>
             </a:fld>
             <a:endParaRPr lang="en-US"/>
           </a:p>
@@ -16745,7 +16745,7 @@
           <a:p>
             <a:fld id="{A25C0F39-45D0-48E9-90B3-7FE8FCE561C8}" type="datetime3">
               <a:rPr lang="en-US" smtClean="0"/>
-              <a:t>4 June 2026</a:t>
+              <a:t>20 July 2026</a:t>
             </a:fld>
             <a:endParaRPr lang="en-US"/>
           </a:p>
@@ -17246,7 +17246,7 @@
           <a:p>
             <a:fld id="{9BAF1A3D-92FA-4F24-9781-74AFA516A230}" type="datetime3">
               <a:rPr lang="en-US" smtClean="0"/>
-              <a:t>4 June 2026</a:t>
+              <a:t>20 July 2026</a:t>
             </a:fld>
             <a:endParaRPr lang="en-US"/>
           </a:p>
@@ -17373,7 +17373,7 @@
           <a:p>
             <a:fld id="{5719C672-856D-4617-A693-8FE15749A9B7}" type="datetime3">
               <a:rPr lang="en-US" smtClean="0"/>
-              <a:t>4 June 2026</a:t>
+              <a:t>20 July 2026</a:t>
             </a:fld>
             <a:endParaRPr lang="en-US"/>
           </a:p>
@@ -17508,7 +17508,7 @@
           <a:p>
             <a:fld id="{5F6C764D-A39E-4C03-B161-E0BC66E8883B}" type="datetime3">
               <a:rPr lang="en-US" smtClean="0"/>
-              <a:t>4 June 2026</a:t>
+              <a:t>20 July 2026</a:t>
             </a:fld>
             <a:endParaRPr lang="en-US"/>
           </a:p>
@@ -17750,7 +17750,7 @@
           <a:p>
             <a:fld id="{6E3E33F9-20B7-4995-BE7D-165DBB597850}" type="datetime3">
               <a:rPr lang="en-US" smtClean="0"/>
-              <a:t>4 June 2026</a:t>
+              <a:t>20 July 2026</a:t>
             </a:fld>
             <a:endParaRPr lang="en-US"/>
           </a:p>
@@ -17863,7 +17863,7 @@
           <a:p>
             <a:fld id="{CD41C263-3501-4369-A962-62B6BF915CDE}" type="datetime3">
               <a:rPr lang="en-US" smtClean="0"/>
-              <a:t>4 June 2026</a:t>
+              <a:t>20 July 2026</a:t>
             </a:fld>
             <a:endParaRPr lang="en-US"/>
           </a:p>
@@ -18266,7 +18266,7 @@
           <a:p>
             <a:fld id="{B06F3EBE-B2E8-4992-9F00-9E4B44F057C0}" type="datetime3">
               <a:rPr lang="en-US" smtClean="0"/>
-              <a:t>4 June 2026</a:t>
+              <a:t>20 July 2026</a:t>
             </a:fld>
             <a:endParaRPr lang="en-US"/>
           </a:p>
@@ -18398,7 +18398,7 @@
           <a:p>
             <a:fld id="{D41656AB-D2E1-472E-8B95-0DF5C6E1D623}" type="datetime3">
               <a:rPr lang="en-US" smtClean="0"/>
-              <a:t>4 June 2026</a:t>
+              <a:t>20 July 2026</a:t>
             </a:fld>
             <a:endParaRPr lang="en-US"/>
           </a:p>
@@ -25647,7 +25647,7 @@
           <a:p>
             <a:fld id="{AD622D1A-DF83-41A8-85FF-04D90BF831D3}" type="datetime3">
               <a:rPr lang="en-US" smtClean="0"/>
-              <a:t>4 June 2026</a:t>
+              <a:t>20 July 2026</a:t>
             </a:fld>
             <a:endParaRPr lang="en-US"/>
           </a:p>
@@ -25897,7 +25897,7 @@
           <a:p>
             <a:fld id="{334F72C3-CDF3-44A8-B602-1649B1728485}" type="datetime3">
               <a:rPr lang="en-US" smtClean="0"/>
-              <a:t>4 June 2026</a:t>
+              <a:t>20 July 2026</a:t>
             </a:fld>
             <a:endParaRPr lang="en-US"/>
           </a:p>
@@ -26204,7 +26204,7 @@
           <a:p>
             <a:fld id="{1E0132BA-B5E7-4FFD-AF6C-169169D47D4A}" type="datetime3">
               <a:rPr lang="en-US" smtClean="0"/>
-              <a:t>4 June 2026</a:t>
+              <a:t>20 July 2026</a:t>
             </a:fld>
             <a:endParaRPr lang="en-US"/>
           </a:p>
@@ -26685,7 +26685,7 @@
           <a:p>
             <a:fld id="{81A30091-1C2A-4151-8D3C-D1E47A72615F}" type="datetime3">
               <a:rPr lang="en-US" smtClean="0"/>
-              <a:t>4 June 2026</a:t>
+              <a:t>20 July 2026</a:t>
             </a:fld>
             <a:endParaRPr lang="en-US"/>
           </a:p>
@@ -27322,7 +27322,7 @@
           <a:p>
             <a:fld id="{35D703CE-07B4-4C05-A488-B4566700621F}" type="datetime3">
               <a:rPr lang="en-US" smtClean="0"/>
-              <a:t>4 June 2026</a:t>
+              <a:t>20 July 2026</a:t>
             </a:fld>
             <a:endParaRPr lang="en-US"/>
           </a:p>
@@ -28380,7 +28380,7 @@
           <a:p>
             <a:fld id="{694BD61C-20BA-43AF-A21F-1DAFB3200099}" type="datetime3">
               <a:rPr lang="en-US" smtClean="0"/>
-              <a:t>4 June 2026</a:t>
+              <a:t>20 July 2026</a:t>
             </a:fld>
             <a:endParaRPr lang="en-US"/>
           </a:p>
@@ -28867,7 +28867,7 @@
           <a:p>
             <a:fld id="{CABCB1B0-B6E5-4DD1-BB55-95C076D6C0C8}" type="datetime3">
               <a:rPr lang="en-US" smtClean="0"/>
-              <a:t>4 June 2026</a:t>
+              <a:t>20 July 2026</a:t>
             </a:fld>
             <a:endParaRPr lang="en-US"/>
           </a:p>
@@ -29822,7 +29822,7 @@
           <a:p>
             <a:fld id="{AD622D1A-DF83-41A8-85FF-04D90BF831D3}" type="datetime3">
               <a:rPr lang="en-US" smtClean="0"/>
-              <a:t>4 June 2026</a:t>
+              <a:t>20 July 2026</a:t>
             </a:fld>
             <a:endParaRPr lang="en-US"/>
           </a:p>
@@ -33530,7 +33530,7 @@
           <a:p>
             <a:fld id="{AD622D1A-DF83-41A8-85FF-04D90BF831D3}" type="datetime3">
               <a:rPr lang="en-US" smtClean="0"/>
-              <a:t>4 June 2026</a:t>
+              <a:t>20 July 2026</a:t>
             </a:fld>
             <a:endParaRPr lang="en-US"/>
           </a:p>
@@ -40210,7 +40210,7 @@
           <a:p>
             <a:fld id="{AD622D1A-DF83-41A8-85FF-04D90BF831D3}" type="datetime3">
               <a:rPr lang="en-US" smtClean="0"/>
-              <a:t>4 June 2026</a:t>
+              <a:t>20 July 2026</a:t>
             </a:fld>
             <a:endParaRPr lang="en-US"/>
           </a:p>
@@ -45891,8 +45891,8 @@
         </p:blipFill>
         <p:spPr>
           <a:xfrm>
-            <a:off x="6441679" y="987425"/>
-            <a:ext cx="3655218" cy="4873625"/>
+            <a:off x="6096000" y="3704"/>
+            <a:ext cx="5140721" cy="6854296"/>
           </a:xfrm>
           <a:prstGeom prst="rect">
             <a:avLst/>
@@ -46041,8 +46041,8 @@
         </p:blipFill>
         <p:spPr>
           <a:xfrm>
-            <a:off x="838200" y="2590816"/>
-            <a:ext cx="5181600" cy="2820955"/>
+            <a:off x="2309351" y="2286868"/>
+            <a:ext cx="7725697" cy="4206007"/>
           </a:xfrm>
           <a:prstGeom prst="rect">
             <a:avLst/>
@@ -46315,13 +46315,9 @@
             </a:pPr>
             <a:r>
               <a:rPr lang="en-US" dirty="0"/>
-              <a:t>What is git and what </a:t>
-            </a:r>
-            <a:r>
-              <a:rPr lang="en-US"/>
-              <a:t>is GitHub?</a:t>
-            </a:r>
-            <a:endParaRPr/>
+              <a:t>What is git and what is GitHub?</a:t>
+            </a:r>
+            <a:endParaRPr dirty="0"/>
           </a:p>
         </p:txBody>
       </p:sp>
@@ -46909,7 +46905,15 @@
             </a:r>
             <a:r>
               <a:rPr lang="en-US" dirty="0"/>
-              <a:t>:  Commits store changes to files</a:t>
+              <a:t>:  Commits store </a:t>
+            </a:r>
+            <a:r>
+              <a:rPr lang="en-US" i="1" dirty="0"/>
+              <a:t>changes</a:t>
+            </a:r>
+            <a:r>
+              <a:rPr lang="en-US" dirty="0"/>
+              <a:t> to files</a:t>
             </a:r>
           </a:p>
           <a:p>
@@ -46974,7 +46978,7 @@
           <a:p>
             <a:fld id="{AD622D1A-DF83-41A8-85FF-04D90BF831D3}" type="datetime3">
               <a:rPr lang="en-US" smtClean="0"/>
-              <a:t>4 June 2026</a:t>
+              <a:t>20 July 2026</a:t>
             </a:fld>
             <a:endParaRPr lang="en-US"/>
           </a:p>
@@ -49513,7 +49517,7 @@
           <a:p>
             <a:fld id="{AD622D1A-DF83-41A8-85FF-04D90BF831D3}" type="datetime3">
               <a:rPr lang="en-US" smtClean="0"/>
-              <a:t>4 June 2026</a:t>
+              <a:t>20 July 2026</a:t>
             </a:fld>
             <a:endParaRPr lang="en-US"/>
           </a:p>
@@ -50855,7 +50859,7 @@
           <a:p>
             <a:fld id="{AD622D1A-DF83-41A8-85FF-04D90BF831D3}" type="datetime3">
               <a:rPr lang="en-US" smtClean="0"/>
-              <a:t>4 June 2026</a:t>
+              <a:t>20 July 2026</a:t>
             </a:fld>
             <a:endParaRPr lang="en-US"/>
           </a:p>

</xml_diff>